<commit_message>
Coadă de import persistentă (SQLite) + aliniere materiale extensie
- storage: migrare schema v2 (tabela import_anunturi, dedup pe sursa_url UNIQUE)
  + metode adauga/listeaza/sterge_anunturi_importate
- descoperire router folosește storage (persistent) în loc de coada in-memory
- Deps: scos câmpul import_coada (înlocuit de SQLite)
- +3 teste (persistență, dedup la nivel SQLite, migrare v1→v2)
- pptx: slide „Date externe" actualizat să reflecte importul prin extensie
- 387 passed, ruff clean

Co-Authored-By: Claude Opus 4.8 (1M context) <noreply@anthropic.com>
</commit_message>
<xml_diff>
--- a/docs/prezentare-aplicatie.pptx
+++ b/docs/prezentare-aplicatie.pptx
@@ -9943,7 +9943,7 @@
         <p:spPr>
           <a:xfrm>
             <a:off x="8046720" y="1920240"/>
-            <a:ext cx="3108960" cy="365760"/>
+            <a:ext cx="3108960" cy="640080"/>
           </a:xfrm>
           <a:prstGeom prst="rect">
             <a:avLst/>
@@ -9959,7 +9959,7 @@
               <a:buNone/>
             </a:pPr>
             <a:r>
-              <a:rPr lang="en-US" sz="1700" b="1" dirty="0">
+              <a:rPr lang="en-US" sz="1600" b="1" dirty="0">
                 <a:solidFill>
                   <a:srgbClr val="D9C08A"/>
                 </a:solidFill>
@@ -9967,9 +9967,9 @@
                 <a:ea typeface="Georgia" pitchFamily="34" charset="-122"/>
                 <a:cs typeface="Georgia" pitchFamily="34" charset="-120"/>
               </a:rPr>
-              <a:t>De ce contează</a:t>
-            </a:r>
-            <a:endParaRPr lang="en-US" sz="1700" dirty="0"/>
+              <a:t>Import prin extensie de browser</a:t>
+            </a:r>
+            <a:endParaRPr lang="en-US" sz="1600" dirty="0"/>
           </a:p>
         </p:txBody>
       </p:sp>
@@ -9981,8 +9981,8 @@
         </p:nvSpPr>
         <p:spPr>
           <a:xfrm>
-            <a:off x="8046720" y="2377440"/>
-            <a:ext cx="3154680" cy="3108960"/>
+            <a:off x="8046720" y="2606040"/>
+            <a:ext cx="3154680" cy="3017520"/>
           </a:xfrm>
           <a:prstGeom prst="rect">
             <a:avLst/>
@@ -9995,10 +9995,13 @@
           <a:lstStyle/>
           <a:p>
             <a:pPr indent="0" marL="0">
-              <a:buNone/>
-            </a:pPr>
-            <a:r>
-              <a:rPr lang="en-US" sz="1400" dirty="0">
+              <a:spcAft>
+                <a:spcPts val="800"/>
+              </a:spcAft>
+              <a:buNone/>
+            </a:pPr>
+            <a:r>
+              <a:rPr lang="en-US" sz="1300" dirty="0">
                 <a:solidFill>
                   <a:srgbClr val="E9E0CC"/>
                 </a:solidFill>
@@ -10006,9 +10009,26 @@
                 <a:ea typeface="Segoe UI" pitchFamily="34" charset="-122"/>
                 <a:cs typeface="Segoe UI" pitchFamily="34" charset="-120"/>
               </a:rPr>
-              <a:t>Evaluatorul înțelege DE CE un anunț e mai relevant decât altul — fără să acceseze documentația tehnică. Comparabilele alese pot popula direct grila; ajustările le pune evaluatorul.</a:t>
-            </a:r>
-            <a:endParaRPr lang="en-US" sz="1400" dirty="0"/>
+              <a:t>Evaluatorul deschide MANUAL un anunț pe storia.ro / imobiliare.ro și apasă un buton — extensia trimite pagina în aplicație. Fără scraping automat, fără anti-bot.</a:t>
+            </a:r>
+            <a:endParaRPr lang="en-US" sz="1300" dirty="0"/>
+          </a:p>
+          <a:p>
+            <a:pPr indent="0" marL="0">
+              <a:buNone/>
+            </a:pPr>
+            <a:r>
+              <a:rPr lang="en-US" sz="1300" dirty="0">
+                <a:solidFill>
+                  <a:srgbClr val="E9E0CC"/>
+                </a:solidFill>
+                <a:latin typeface="Segoe UI" pitchFamily="34" charset="0"/>
+                <a:ea typeface="Segoe UI" pitchFamily="34" charset="-122"/>
+                <a:cs typeface="Segoe UI" pitchFamily="34" charset="-120"/>
+              </a:rPr>
+              <a:t>Anunțurile intră într-o coadă persistentă; din ele populează direct grila. Prețurile sunt din OFERTE — ajustarea ofertă→tranzacție o pune evaluatorul.</a:t>
+            </a:r>
+            <a:endParaRPr lang="en-US" sz="1300" dirty="0"/>
           </a:p>
         </p:txBody>
       </p:sp>

</xml_diff>